<commit_message>
Upload complete project: Dashboards, SQL, and README
</commit_message>
<xml_diff>
--- a/Presentation/Superstore BI & Data Analytics.pptx
+++ b/Presentation/Superstore BI & Data Analytics.pptx
@@ -3307,322 +3307,6 @@
           </a:p>
         </p:txBody>
       </p:sp>
-      <p:grpSp>
-        <p:nvGrpSpPr>
-          <p:cNvPr id="7" name="Group 7"/>
-          <p:cNvGrpSpPr/>
-          <p:nvPr/>
-        </p:nvGrpSpPr>
-        <p:grpSpPr>
-          <a:xfrm>
-            <a:off x="3218572" y="7527704"/>
-            <a:ext cx="2772573" cy="1578195"/>
-            <a:chOff x="0" y="47625"/>
-            <a:chExt cx="3696764" cy="1748048"/>
-          </a:xfrm>
-        </p:grpSpPr>
-        <p:grpSp>
-          <p:nvGrpSpPr>
-            <p:cNvPr id="8" name="Group 8"/>
-            <p:cNvGrpSpPr/>
-            <p:nvPr/>
-          </p:nvGrpSpPr>
-          <p:grpSpPr>
-            <a:xfrm>
-              <a:off x="0" y="385418"/>
-              <a:ext cx="134591" cy="134591"/>
-              <a:chOff x="0" y="0"/>
-              <a:chExt cx="812800" cy="812800"/>
-            </a:xfrm>
-          </p:grpSpPr>
-          <p:sp>
-            <p:nvSpPr>
-              <p:cNvPr id="9" name="Freeform 9"/>
-              <p:cNvSpPr/>
-              <p:nvPr/>
-            </p:nvSpPr>
-            <p:spPr>
-              <a:xfrm>
-                <a:off x="0" y="0"/>
-                <a:ext cx="812800" cy="812800"/>
-              </a:xfrm>
-              <a:custGeom>
-                <a:avLst/>
-                <a:gdLst/>
-                <a:ahLst/>
-                <a:cxnLst/>
-                <a:rect l="l" t="t" r="r" b="b"/>
-                <a:pathLst>
-                  <a:path w="812800" h="812800">
-                    <a:moveTo>
-                      <a:pt x="406400" y="0"/>
-                    </a:moveTo>
-                    <a:cubicBezTo>
-                      <a:pt x="181951" y="0"/>
-                      <a:pt x="0" y="181951"/>
-                      <a:pt x="0" y="406400"/>
-                    </a:cubicBezTo>
-                    <a:cubicBezTo>
-                      <a:pt x="0" y="630849"/>
-                      <a:pt x="181951" y="812800"/>
-                      <a:pt x="406400" y="812800"/>
-                    </a:cubicBezTo>
-                    <a:cubicBezTo>
-                      <a:pt x="630849" y="812800"/>
-                      <a:pt x="812800" y="630849"/>
-                      <a:pt x="812800" y="406400"/>
-                    </a:cubicBezTo>
-                    <a:cubicBezTo>
-                      <a:pt x="812800" y="181951"/>
-                      <a:pt x="630849" y="0"/>
-                      <a:pt x="406400" y="0"/>
-                    </a:cubicBezTo>
-                    <a:close/>
-                  </a:path>
-                </a:pathLst>
-              </a:custGeom>
-              <a:gradFill rotWithShape="1">
-                <a:gsLst>
-                  <a:gs pos="0">
-                    <a:srgbClr val="293E9C">
-                      <a:alpha val="100000"/>
-                    </a:srgbClr>
-                  </a:gs>
-                  <a:gs pos="100000">
-                    <a:srgbClr val="3A58E4">
-                      <a:alpha val="100000"/>
-                    </a:srgbClr>
-                  </a:gs>
-                </a:gsLst>
-                <a:path path="circle">
-                  <a:fillToRect r="100000" b="100000"/>
-                </a:path>
-                <a:tileRect l="-100000" t="-100000"/>
-              </a:gradFill>
-            </p:spPr>
-            <p:txBody>
-              <a:bodyPr/>
-              <a:lstStyle/>
-              <a:p>
-                <a:endParaRPr lang="en-US"/>
-              </a:p>
-            </p:txBody>
-          </p:sp>
-          <p:sp>
-            <p:nvSpPr>
-              <p:cNvPr id="10" name="TextBox 10"/>
-              <p:cNvSpPr txBox="1"/>
-              <p:nvPr/>
-            </p:nvSpPr>
-            <p:spPr>
-              <a:xfrm>
-                <a:off x="76200" y="104775"/>
-                <a:ext cx="660400" cy="631825"/>
-              </a:xfrm>
-              <a:prstGeom prst="rect">
-                <a:avLst/>
-              </a:prstGeom>
-            </p:spPr>
-            <p:txBody>
-              <a:bodyPr lIns="50800" tIns="50800" rIns="50800" bIns="50800" rtlCol="0" anchor="ctr"/>
-              <a:lstStyle/>
-              <a:p>
-                <a:pPr marL="0" lvl="0" indent="0" algn="ctr">
-                  <a:lnSpc>
-                    <a:spcPts val="1308"/>
-                  </a:lnSpc>
-                </a:pPr>
-                <a:endParaRPr dirty="0"/>
-              </a:p>
-            </p:txBody>
-          </p:sp>
-        </p:grpSp>
-        <p:sp>
-          <p:nvSpPr>
-            <p:cNvPr id="11" name="TextBox 11"/>
-            <p:cNvSpPr txBox="1"/>
-            <p:nvPr/>
-          </p:nvSpPr>
-          <p:spPr>
-            <a:xfrm>
-              <a:off x="506484" y="47625"/>
-              <a:ext cx="2749098" cy="381297"/>
-            </a:xfrm>
-            <a:prstGeom prst="rect">
-              <a:avLst/>
-            </a:prstGeom>
-          </p:spPr>
-          <p:txBody>
-            <a:bodyPr lIns="0" tIns="0" rIns="0" bIns="0" rtlCol="0" anchor="t">
-              <a:spAutoFit/>
-            </a:bodyPr>
-            <a:lstStyle/>
-            <a:p>
-              <a:pPr marL="0" lvl="0" indent="0" algn="l">
-                <a:lnSpc>
-                  <a:spcPts val="1869"/>
-                </a:lnSpc>
-              </a:pPr>
-              <a:r>
-                <a:rPr lang="en-US" sz="2149" b="1" dirty="0">
-                  <a:gradFill>
-                    <a:gsLst>
-                      <a:gs pos="0">
-                        <a:srgbClr val="293E9C">
-                          <a:alpha val="100000"/>
-                        </a:srgbClr>
-                      </a:gs>
-                      <a:gs pos="100000">
-                        <a:srgbClr val="3A58E4">
-                          <a:alpha val="100000"/>
-                        </a:srgbClr>
-                      </a:gs>
-                    </a:gsLst>
-                    <a:path path="circle">
-                      <a:fillToRect r="100000" b="100000"/>
-                    </a:path>
-                    <a:tileRect l="-100000" t="-100000"/>
-                  </a:gradFill>
-                  <a:latin typeface="Poppins Bold"/>
-                  <a:ea typeface="Poppins Bold"/>
-                  <a:cs typeface="Poppins Bold"/>
-                  <a:sym typeface="Poppins Bold"/>
-                </a:rPr>
-                <a:t>PRESENTED BY</a:t>
-              </a:r>
-            </a:p>
-          </p:txBody>
-        </p:sp>
-        <p:sp>
-          <p:nvSpPr>
-            <p:cNvPr id="12" name="TextBox 12"/>
-            <p:cNvSpPr txBox="1"/>
-            <p:nvPr/>
-          </p:nvSpPr>
-          <p:spPr>
-            <a:xfrm>
-              <a:off x="506484" y="536670"/>
-              <a:ext cx="3190280" cy="327269"/>
-            </a:xfrm>
-            <a:prstGeom prst="rect">
-              <a:avLst/>
-            </a:prstGeom>
-          </p:spPr>
-          <p:txBody>
-            <a:bodyPr lIns="0" tIns="0" rIns="0" bIns="0" rtlCol="0" anchor="t">
-              <a:spAutoFit/>
-            </a:bodyPr>
-            <a:lstStyle/>
-            <a:p>
-              <a:pPr marL="0" lvl="0" indent="0" algn="l">
-                <a:lnSpc>
-                  <a:spcPts val="1752"/>
-                </a:lnSpc>
-              </a:pPr>
-              <a:r>
-                <a:rPr lang="en-US" sz="2014" dirty="0">
-                  <a:gradFill>
-                    <a:gsLst>
-                      <a:gs pos="0">
-                        <a:srgbClr val="293E9C">
-                          <a:alpha val="100000"/>
-                        </a:srgbClr>
-                      </a:gs>
-                      <a:gs pos="100000">
-                        <a:srgbClr val="3A58E4">
-                          <a:alpha val="100000"/>
-                        </a:srgbClr>
-                      </a:gs>
-                    </a:gsLst>
-                    <a:path path="circle">
-                      <a:fillToRect r="100000" b="100000"/>
-                    </a:path>
-                    <a:tileRect l="-100000" t="-100000"/>
-                  </a:gradFill>
-                  <a:latin typeface="Poppins"/>
-                  <a:ea typeface="Poppins"/>
-                  <a:cs typeface="Poppins"/>
-                  <a:sym typeface="Poppins"/>
-                </a:rPr>
-                <a:t>Mohanad Ibrahim</a:t>
-              </a:r>
-            </a:p>
-          </p:txBody>
-        </p:sp>
-        <p:sp>
-          <p:nvSpPr>
-            <p:cNvPr id="16" name="Freeform 16"/>
-            <p:cNvSpPr/>
-            <p:nvPr/>
-          </p:nvSpPr>
-          <p:spPr>
-            <a:xfrm>
-              <a:off x="0" y="1661082"/>
-              <a:ext cx="134591" cy="134591"/>
-            </a:xfrm>
-            <a:custGeom>
-              <a:avLst/>
-              <a:gdLst/>
-              <a:ahLst/>
-              <a:cxnLst/>
-              <a:rect l="l" t="t" r="r" b="b"/>
-              <a:pathLst>
-                <a:path w="812800" h="812800">
-                  <a:moveTo>
-                    <a:pt x="406400" y="0"/>
-                  </a:moveTo>
-                  <a:cubicBezTo>
-                    <a:pt x="181951" y="0"/>
-                    <a:pt x="0" y="181951"/>
-                    <a:pt x="0" y="406400"/>
-                  </a:cubicBezTo>
-                  <a:cubicBezTo>
-                    <a:pt x="0" y="630849"/>
-                    <a:pt x="181951" y="812800"/>
-                    <a:pt x="406400" y="812800"/>
-                  </a:cubicBezTo>
-                  <a:cubicBezTo>
-                    <a:pt x="630849" y="812800"/>
-                    <a:pt x="812800" y="630849"/>
-                    <a:pt x="812800" y="406400"/>
-                  </a:cubicBezTo>
-                  <a:cubicBezTo>
-                    <a:pt x="812800" y="181951"/>
-                    <a:pt x="630849" y="0"/>
-                    <a:pt x="406400" y="0"/>
-                  </a:cubicBezTo>
-                  <a:close/>
-                </a:path>
-              </a:pathLst>
-            </a:custGeom>
-            <a:gradFill rotWithShape="1">
-              <a:gsLst>
-                <a:gs pos="0">
-                  <a:srgbClr val="293E9C">
-                    <a:alpha val="100000"/>
-                  </a:srgbClr>
-                </a:gs>
-                <a:gs pos="100000">
-                  <a:srgbClr val="3A58E4">
-                    <a:alpha val="100000"/>
-                  </a:srgbClr>
-                </a:gs>
-              </a:gsLst>
-              <a:path path="circle">
-                <a:fillToRect r="100000" b="100000"/>
-              </a:path>
-              <a:tileRect l="-100000" t="-100000"/>
-            </a:gradFill>
-          </p:spPr>
-          <p:txBody>
-            <a:bodyPr/>
-            <a:lstStyle/>
-            <a:p>
-              <a:endParaRPr lang="en-US"/>
-            </a:p>
-          </p:txBody>
-        </p:sp>
-      </p:grpSp>
       <p:sp>
         <p:nvSpPr>
           <p:cNvPr id="18" name="TextBox 18"/>
@@ -3986,6 +3670,130 @@
           </p:txBody>
         </p:sp>
       </p:grpSp>
+      <p:sp>
+        <p:nvSpPr>
+          <p:cNvPr id="13" name="TextBox 11">
+            <a:extLst>
+              <a:ext uri="{FF2B5EF4-FFF2-40B4-BE49-F238E27FC236}">
+                <a16:creationId xmlns:a16="http://schemas.microsoft.com/office/drawing/2014/main" id="{32380918-F422-612E-F5F0-EFE4EA43A575}"/>
+              </a:ext>
+            </a:extLst>
+          </p:cNvPr>
+          <p:cNvSpPr txBox="1"/>
+          <p:nvPr/>
+        </p:nvSpPr>
+        <p:spPr>
+          <a:xfrm>
+            <a:off x="5448566" y="7469857"/>
+            <a:ext cx="2061824" cy="344247"/>
+          </a:xfrm>
+          <a:prstGeom prst="rect">
+            <a:avLst/>
+          </a:prstGeom>
+        </p:spPr>
+        <p:txBody>
+          <a:bodyPr lIns="0" tIns="0" rIns="0" bIns="0" rtlCol="0" anchor="t">
+            <a:spAutoFit/>
+          </a:bodyPr>
+          <a:lstStyle/>
+          <a:p>
+            <a:pPr marL="0" lvl="0" indent="0" algn="l">
+              <a:lnSpc>
+                <a:spcPts val="1869"/>
+              </a:lnSpc>
+            </a:pPr>
+            <a:r>
+              <a:rPr lang="en-US" sz="2149" b="1" dirty="0">
+                <a:gradFill>
+                  <a:gsLst>
+                    <a:gs pos="0">
+                      <a:srgbClr val="293E9C">
+                        <a:alpha val="100000"/>
+                      </a:srgbClr>
+                    </a:gs>
+                    <a:gs pos="100000">
+                      <a:srgbClr val="3A58E4">
+                        <a:alpha val="100000"/>
+                      </a:srgbClr>
+                    </a:gs>
+                  </a:gsLst>
+                  <a:path path="circle">
+                    <a:fillToRect r="100000" b="100000"/>
+                  </a:path>
+                  <a:tileRect l="-100000" t="-100000"/>
+                </a:gradFill>
+                <a:latin typeface="Poppins Bold"/>
+                <a:ea typeface="Poppins Bold"/>
+                <a:cs typeface="Poppins Bold"/>
+                <a:sym typeface="Poppins Bold"/>
+              </a:rPr>
+              <a:t>PRESENTED BY</a:t>
+            </a:r>
+          </a:p>
+        </p:txBody>
+      </p:sp>
+      <p:sp>
+        <p:nvSpPr>
+          <p:cNvPr id="14" name="TextBox 12">
+            <a:extLst>
+              <a:ext uri="{FF2B5EF4-FFF2-40B4-BE49-F238E27FC236}">
+                <a16:creationId xmlns:a16="http://schemas.microsoft.com/office/drawing/2014/main" id="{1D438EFC-8648-CD04-8AE6-D09A038E06D6}"/>
+              </a:ext>
+            </a:extLst>
+          </p:cNvPr>
+          <p:cNvSpPr txBox="1"/>
+          <p:nvPr/>
+        </p:nvSpPr>
+        <p:spPr>
+          <a:xfrm>
+            <a:off x="5283123" y="7972017"/>
+            <a:ext cx="2392710" cy="295469"/>
+          </a:xfrm>
+          <a:prstGeom prst="rect">
+            <a:avLst/>
+          </a:prstGeom>
+        </p:spPr>
+        <p:txBody>
+          <a:bodyPr lIns="0" tIns="0" rIns="0" bIns="0" rtlCol="0" anchor="t">
+            <a:spAutoFit/>
+          </a:bodyPr>
+          <a:lstStyle/>
+          <a:p>
+            <a:pPr marL="0" lvl="0" indent="0" algn="l">
+              <a:lnSpc>
+                <a:spcPts val="1752"/>
+              </a:lnSpc>
+            </a:pPr>
+            <a:r>
+              <a:rPr lang="en-US" sz="2014" dirty="0">
+                <a:gradFill>
+                  <a:gsLst>
+                    <a:gs pos="0">
+                      <a:srgbClr val="293E9C">
+                        <a:alpha val="100000"/>
+                      </a:srgbClr>
+                    </a:gs>
+                    <a:gs pos="100000">
+                      <a:srgbClr val="3A58E4">
+                        <a:alpha val="100000"/>
+                      </a:srgbClr>
+                    </a:gs>
+                  </a:gsLst>
+                  <a:path path="circle">
+                    <a:fillToRect r="100000" b="100000"/>
+                  </a:path>
+                  <a:tileRect l="-100000" t="-100000"/>
+                </a:gradFill>
+                <a:latin typeface="Poppins"/>
+                <a:ea typeface="Poppins"/>
+                <a:cs typeface="Poppins"/>
+                <a:sym typeface="Poppins"/>
+              </a:rPr>
+              <a:t>Mohanad Ibrahim</a:t>
+            </a:r>
+          </a:p>
+        </p:txBody>
+      </p:sp>
     </p:spTree>
   </p:cSld>
   <p:clrMapOvr>
@@ -13173,10 +12981,10 @@
       </p:sp>
       <p:pic>
         <p:nvPicPr>
-          <p:cNvPr id="20" name="Picture 19">
+          <p:cNvPr id="21" name="Picture 20">
             <a:extLst>
               <a:ext uri="{FF2B5EF4-FFF2-40B4-BE49-F238E27FC236}">
-                <a16:creationId xmlns:a16="http://schemas.microsoft.com/office/drawing/2014/main" id="{4664F7B5-F9DB-3AE7-79F3-BEBEF3156E22}"/>
+                <a16:creationId xmlns:a16="http://schemas.microsoft.com/office/drawing/2014/main" id="{1CD64635-5BF9-DA7A-BDC3-9878D6D15B88}"/>
               </a:ext>
             </a:extLst>
           </p:cNvPr>
@@ -13199,8 +13007,8 @@
         </p:blipFill>
         <p:spPr>
           <a:xfrm>
-            <a:off x="9832" y="1"/>
-            <a:ext cx="6532962" cy="5320770"/>
+            <a:off x="-1" y="1"/>
+            <a:ext cx="6553846" cy="5320768"/>
           </a:xfrm>
           <a:prstGeom prst="rect">
             <a:avLst/>
@@ -13726,10 +13534,10 @@
       </p:sp>
       <p:pic>
         <p:nvPicPr>
-          <p:cNvPr id="16" name="Picture 15">
+          <p:cNvPr id="17" name="Picture 16">
             <a:extLst>
               <a:ext uri="{FF2B5EF4-FFF2-40B4-BE49-F238E27FC236}">
-                <a16:creationId xmlns:a16="http://schemas.microsoft.com/office/drawing/2014/main" id="{B42F62AE-AB22-FB5C-6A74-62C75A384B8B}"/>
+                <a16:creationId xmlns:a16="http://schemas.microsoft.com/office/drawing/2014/main" id="{6DBAD3BC-1D7D-464E-B70E-AA3F03909DAD}"/>
               </a:ext>
             </a:extLst>
           </p:cNvPr>
@@ -13752,8 +13560,8 @@
         </p:blipFill>
         <p:spPr>
           <a:xfrm>
-            <a:off x="9144000" y="2089974"/>
-            <a:ext cx="9144000" cy="6785997"/>
+            <a:off x="9144000" y="1848167"/>
+            <a:ext cx="9068128" cy="7027804"/>
           </a:xfrm>
           <a:prstGeom prst="rect">
             <a:avLst/>
@@ -15770,10 +15578,10 @@
       </p:sp>
       <p:pic>
         <p:nvPicPr>
-          <p:cNvPr id="20" name="Picture 19">
+          <p:cNvPr id="21" name="Picture 20">
             <a:extLst>
               <a:ext uri="{FF2B5EF4-FFF2-40B4-BE49-F238E27FC236}">
-                <a16:creationId xmlns:a16="http://schemas.microsoft.com/office/drawing/2014/main" id="{D7258780-5F9D-470F-6F81-C5D099BA28FB}"/>
+                <a16:creationId xmlns:a16="http://schemas.microsoft.com/office/drawing/2014/main" id="{A56DCD99-8E98-CC07-FB22-1C2733854475}"/>
               </a:ext>
             </a:extLst>
           </p:cNvPr>
@@ -15796,8 +15604,8 @@
         </p:blipFill>
         <p:spPr>
           <a:xfrm>
-            <a:off x="-24580" y="-27163"/>
-            <a:ext cx="6578426" cy="5347932"/>
+            <a:off x="1" y="10460"/>
+            <a:ext cx="6542794" cy="5310309"/>
           </a:xfrm>
           <a:prstGeom prst="rect">
             <a:avLst/>

</xml_diff>